<commit_message>
De-brand: present as an independent personal project
- Remove the Capital Group logo from all games (header now shows only the
  'THE LONG GAME' wordmark) and drop the 'internal use only' footer.
- Genericize the Sales edition: 'American Balanced Fund'/ABALX → a generic
  'Balanced Fund', remove the ticker and the external advisor call-to-action.
- Replace 'The Capital System' framing with a neutral long-term-investing line;
  genericize all disclaimers.
- De-brand the consultant deck + FAQ (title, footers, and the logo baked into
  the embedded screenshots) and regenerate their PDFs.
- De-brand the archived prototypes and the docs; add a personal-project note to
  the README; remove the internal compliance checklist and branded binary guides.
- Regenerate README screenshots against the de-branded games.

Co-Authored-By: Claude Opus 4.8 <noreply@anthropic.com>
Claude-Session: https://claude.ai/code/session_01EfdgwHTKZvsSK3ggYc4z9J
</commit_message>
<xml_diff>
--- a/consultant-materials/The-Long-Game-Live-Walkthrough.pptx
+++ b/consultant-materials/The-Long-Game-Live-Walkthrough.pptx
@@ -3226,7 +3226,7 @@
                 </a:solidFill>
                 <a:latin typeface="Calibri"/>
               </a:rPr>
-              <a:t>CAPITAL GROUP   ·   THE LONG GAME</a:t>
+              <a:t>THE LONG GAME</a:t>
             </a:r>
           </a:p>
         </p:txBody>
@@ -3371,7 +3371,7 @@
                 </a:solidFill>
                 <a:latin typeface="Calibri"/>
               </a:rPr>
-              <a:t>Internal use only · Do not disseminate</a:t>
+              <a:t>A personal project · interactive investing game</a:t>
             </a:r>
           </a:p>
         </p:txBody>
@@ -3899,7 +3899,7 @@
                 </a:solidFill>
                 <a:latin typeface="Calibri"/>
               </a:rPr>
-              <a:t>THE LONG GAME · LIVE ROOM      ·      HOW IT WORKS, AND WHY      ·      INTERNAL USE ONLY</a:t>
+              <a:t>THE LONG GAME · LIVE ROOM      ·      HOW IT WORKS, AND WHY</a:t>
             </a:r>
           </a:p>
         </p:txBody>
@@ -4427,7 +4427,7 @@
                 </a:solidFill>
                 <a:latin typeface="Calibri"/>
               </a:rPr>
-              <a:t>THE LONG GAME · LIVE ROOM      ·      HOW IT WORKS, AND WHY      ·      INTERNAL USE ONLY</a:t>
+              <a:t>THE LONG GAME · LIVE ROOM      ·      HOW IT WORKS, AND WHY</a:t>
             </a:r>
           </a:p>
         </p:txBody>
@@ -4955,7 +4955,7 @@
                 </a:solidFill>
                 <a:latin typeface="Calibri"/>
               </a:rPr>
-              <a:t>THE LONG GAME · LIVE ROOM      ·      HOW IT WORKS, AND WHY      ·      INTERNAL USE ONLY</a:t>
+              <a:t>THE LONG GAME · LIVE ROOM      ·      HOW IT WORKS, AND WHY</a:t>
             </a:r>
           </a:p>
         </p:txBody>
@@ -5762,7 +5762,7 @@
                 </a:solidFill>
                 <a:latin typeface="Calibri"/>
               </a:rPr>
-              <a:t>THE LONG GAME · LIVE ROOM      ·      HOW IT WORKS, AND WHY      ·      INTERNAL USE ONLY</a:t>
+              <a:t>THE LONG GAME · LIVE ROOM      ·      HOW IT WORKS, AND WHY</a:t>
             </a:r>
           </a:p>
         </p:txBody>
@@ -6596,7 +6596,7 @@
                 </a:solidFill>
                 <a:latin typeface="Calibri"/>
               </a:rPr>
-              <a:t>THE LONG GAME · LIVE ROOM      ·      HOW IT WORKS, AND WHY      ·      INTERNAL USE ONLY</a:t>
+              <a:t>THE LONG GAME · LIVE ROOM      ·      HOW IT WORKS, AND WHY</a:t>
             </a:r>
           </a:p>
         </p:txBody>
@@ -7732,7 +7732,7 @@
                 </a:solidFill>
                 <a:latin typeface="Calibri"/>
               </a:rPr>
-              <a:t>THE LONG GAME · LIVE ROOM      ·      HOW IT WORKS, AND WHY      ·      INTERNAL USE ONLY</a:t>
+              <a:t>THE LONG GAME · LIVE ROOM      ·      HOW IT WORKS, AND WHY</a:t>
             </a:r>
           </a:p>
         </p:txBody>
@@ -8260,7 +8260,7 @@
                 </a:solidFill>
                 <a:latin typeface="Calibri"/>
               </a:rPr>
-              <a:t>THE LONG GAME · LIVE ROOM      ·      HOW IT WORKS, AND WHY      ·      INTERNAL USE ONLY</a:t>
+              <a:t>THE LONG GAME · LIVE ROOM      ·      HOW IT WORKS, AND WHY</a:t>
             </a:r>
           </a:p>
         </p:txBody>
@@ -8788,7 +8788,7 @@
                 </a:solidFill>
                 <a:latin typeface="Calibri"/>
               </a:rPr>
-              <a:t>THE LONG GAME · LIVE ROOM      ·      HOW IT WORKS, AND WHY      ·      INTERNAL USE ONLY</a:t>
+              <a:t>THE LONG GAME · LIVE ROOM      ·      HOW IT WORKS, AND WHY</a:t>
             </a:r>
           </a:p>
         </p:txBody>
@@ -9316,7 +9316,7 @@
                 </a:solidFill>
                 <a:latin typeface="Calibri"/>
               </a:rPr>
-              <a:t>THE LONG GAME · LIVE ROOM      ·      HOW IT WORKS, AND WHY      ·      INTERNAL USE ONLY</a:t>
+              <a:t>THE LONG GAME · LIVE ROOM      ·      HOW IT WORKS, AND WHY</a:t>
             </a:r>
           </a:p>
         </p:txBody>
@@ -9844,7 +9844,7 @@
                 </a:solidFill>
                 <a:latin typeface="Calibri"/>
               </a:rPr>
-              <a:t>THE LONG GAME · LIVE ROOM      ·      HOW IT WORKS, AND WHY      ·      INTERNAL USE ONLY</a:t>
+              <a:t>THE LONG GAME · LIVE ROOM      ·      HOW IT WORKS, AND WHY</a:t>
             </a:r>
           </a:p>
         </p:txBody>
@@ -10372,7 +10372,7 @@
                 </a:solidFill>
                 <a:latin typeface="Calibri"/>
               </a:rPr>
-              <a:t>THE LONG GAME · LIVE ROOM      ·      HOW IT WORKS, AND WHY      ·      INTERNAL USE ONLY</a:t>
+              <a:t>THE LONG GAME · LIVE ROOM      ·      HOW IT WORKS, AND WHY</a:t>
             </a:r>
           </a:p>
         </p:txBody>
@@ -10900,7 +10900,7 @@
                 </a:solidFill>
                 <a:latin typeface="Calibri"/>
               </a:rPr>
-              <a:t>THE LONG GAME · LIVE ROOM      ·      HOW IT WORKS, AND WHY      ·      INTERNAL USE ONLY</a:t>
+              <a:t>THE LONG GAME · LIVE ROOM      ·      HOW IT WORKS, AND WHY</a:t>
             </a:r>
           </a:p>
         </p:txBody>
@@ -11428,7 +11428,7 @@
                 </a:solidFill>
                 <a:latin typeface="Calibri"/>
               </a:rPr>
-              <a:t>THE LONG GAME · LIVE ROOM      ·      HOW IT WORKS, AND WHY      ·      INTERNAL USE ONLY</a:t>
+              <a:t>THE LONG GAME · LIVE ROOM      ·      HOW IT WORKS, AND WHY</a:t>
             </a:r>
           </a:p>
         </p:txBody>

</xml_diff>